<commit_message>
Final Push | Presentation Over
</commit_message>
<xml_diff>
--- a/Presentations/End_Sem_Presentation_Grp11.pptx
+++ b/Presentations/End_Sem_Presentation_Grp11.pptx
@@ -14517,37 +14517,6 @@
                 <a:cs typeface="Times New Roman"/>
                 <a:sym typeface="Times New Roman"/>
               </a:rPr>
-              <a:t>Application in Robotics and Medical Imaging</a:t>
-            </a:r>
-            <a:endParaRPr sz="2300">
-              <a:latin typeface="Times New Roman"/>
-              <a:ea typeface="Times New Roman"/>
-              <a:cs typeface="Times New Roman"/>
-              <a:sym typeface="Times New Roman"/>
-            </a:endParaRPr>
-          </a:p>
-          <a:p>
-            <a:pPr indent="-374650" lvl="0" marL="457200" rtl="0" algn="l">
-              <a:lnSpc>
-                <a:spcPct val="150000"/>
-              </a:lnSpc>
-              <a:spcBef>
-                <a:spcPts val="0"/>
-              </a:spcBef>
-              <a:spcAft>
-                <a:spcPts val="0"/>
-              </a:spcAft>
-              <a:buSzPts val="2300"/>
-              <a:buFont typeface="Times New Roman"/>
-              <a:buChar char="•"/>
-            </a:pPr>
-            <a:r>
-              <a:rPr lang="en-US" sz="2300">
-                <a:latin typeface="Times New Roman"/>
-                <a:ea typeface="Times New Roman"/>
-                <a:cs typeface="Times New Roman"/>
-                <a:sym typeface="Times New Roman"/>
-              </a:rPr>
               <a:t>Motivation: Diamonds’ precision geometry </a:t>
             </a:r>
             <a:endParaRPr sz="2300">
@@ -14838,7 +14807,7 @@
         </p:blipFill>
         <p:spPr>
           <a:xfrm>
-            <a:off x="8117950" y="1773245"/>
+            <a:off x="7763800" y="1309195"/>
             <a:ext cx="3483248" cy="1959325"/>
           </a:xfrm>
           <a:prstGeom prst="rect">
@@ -14866,7 +14835,7 @@
         </p:blipFill>
         <p:spPr>
           <a:xfrm>
-            <a:off x="8378425" y="3946097"/>
+            <a:off x="8024275" y="3553797"/>
             <a:ext cx="2962301" cy="2507584"/>
           </a:xfrm>
           <a:prstGeom prst="rect">
@@ -15483,7 +15452,7 @@
             <a:tbl>
               <a:tblPr>
                 <a:noFill/>
-                <a:tableStyleId>{550190C3-7411-4B4B-96EF-009C839F0915}</a:tableStyleId>
+                <a:tableStyleId>{AA87A85F-2535-4754-8D24-BC57B00E8C40}</a:tableStyleId>
               </a:tblPr>
               <a:tblGrid>
                 <a:gridCol w="4533850"/>
@@ -15681,7 +15650,7 @@
             <a:tbl>
               <a:tblPr>
                 <a:noFill/>
-                <a:tableStyleId>{550190C3-7411-4B4B-96EF-009C839F0915}</a:tableStyleId>
+                <a:tableStyleId>{AA87A85F-2535-4754-8D24-BC57B00E8C40}</a:tableStyleId>
               </a:tblPr>
               <a:tblGrid>
                 <a:gridCol w="4318775"/>
@@ -15918,7 +15887,7 @@
             <a:tbl>
               <a:tblPr>
                 <a:noFill/>
-                <a:tableStyleId>{550190C3-7411-4B4B-96EF-009C839F0915}</a:tableStyleId>
+                <a:tableStyleId>{AA87A85F-2535-4754-8D24-BC57B00E8C40}</a:tableStyleId>
               </a:tblPr>
               <a:tblGrid>
                 <a:gridCol w="4533850"/>
@@ -15953,7 +15922,7 @@
                           <a:cs typeface="Times New Roman"/>
                           <a:sym typeface="Times New Roman"/>
                         </a:rPr>
-                        <a:t>Generated synthetic silhouettes of sphere using simple shapes</a:t>
+                        <a:t>Generated synthetic silhouettes of sphere using simple shape</a:t>
                       </a:r>
                       <a:br>
                         <a:rPr lang="en-US" sz="1300">
@@ -16565,7 +16534,7 @@
             <a:tbl>
               <a:tblPr>
                 <a:noFill/>
-                <a:tableStyleId>{550190C3-7411-4B4B-96EF-009C839F0915}</a:tableStyleId>
+                <a:tableStyleId>{AA87A85F-2535-4754-8D24-BC57B00E8C40}</a:tableStyleId>
               </a:tblPr>
               <a:tblGrid>
                 <a:gridCol w="5162375"/>
@@ -16756,7 +16725,67 @@
                           <a:cs typeface="Times New Roman"/>
                           <a:sym typeface="Times New Roman"/>
                         </a:rPr>
-                        <a:t>0.9 rad, 1.8 rad, 3.6 rad</a:t>
+                        <a:t>0.9</a:t>
+                      </a:r>
+                      <a:r>
+                        <a:rPr lang="en-US" sz="1500">
+                          <a:solidFill>
+                            <a:schemeClr val="dk1"/>
+                          </a:solidFill>
+                          <a:latin typeface="Times New Roman"/>
+                          <a:ea typeface="Times New Roman"/>
+                          <a:cs typeface="Times New Roman"/>
+                          <a:sym typeface="Times New Roman"/>
+                        </a:rPr>
+                        <a:t>°</a:t>
+                      </a:r>
+                      <a:r>
+                        <a:rPr b="1" lang="en-US" sz="1500">
+                          <a:solidFill>
+                            <a:schemeClr val="dk1"/>
+                          </a:solidFill>
+                          <a:latin typeface="Times New Roman"/>
+                          <a:ea typeface="Times New Roman"/>
+                          <a:cs typeface="Times New Roman"/>
+                          <a:sym typeface="Times New Roman"/>
+                        </a:rPr>
+                        <a:t>, 1.8</a:t>
+                      </a:r>
+                      <a:r>
+                        <a:rPr lang="en-US" sz="1500">
+                          <a:solidFill>
+                            <a:schemeClr val="dk1"/>
+                          </a:solidFill>
+                          <a:latin typeface="Times New Roman"/>
+                          <a:ea typeface="Times New Roman"/>
+                          <a:cs typeface="Times New Roman"/>
+                          <a:sym typeface="Times New Roman"/>
+                        </a:rPr>
+                        <a:t>°</a:t>
+                      </a:r>
+                      <a:r>
+                        <a:rPr b="1" lang="en-US" sz="1500">
+                          <a:solidFill>
+                            <a:schemeClr val="dk1"/>
+                          </a:solidFill>
+                          <a:latin typeface="Times New Roman"/>
+                          <a:ea typeface="Times New Roman"/>
+                          <a:cs typeface="Times New Roman"/>
+                          <a:sym typeface="Times New Roman"/>
+                        </a:rPr>
+                        <a:t>, 3.6</a:t>
+                      </a:r>
+                      <a:r>
+                        <a:rPr lang="en-US" sz="1500">
+                          <a:solidFill>
+                            <a:schemeClr val="dk1"/>
+                          </a:solidFill>
+                          <a:latin typeface="Times New Roman"/>
+                          <a:ea typeface="Times New Roman"/>
+                          <a:cs typeface="Times New Roman"/>
+                          <a:sym typeface="Times New Roman"/>
+                        </a:rPr>
+                        <a:t>°</a:t>
                       </a:r>
                       <a:endParaRPr sz="1500">
                         <a:solidFill>
@@ -18003,8 +18032,8 @@
         </p:nvSpPr>
         <p:spPr>
           <a:xfrm>
-            <a:off x="594302" y="1326300"/>
-            <a:ext cx="10515600" cy="4351200"/>
+            <a:off x="1078725" y="1326300"/>
+            <a:ext cx="10031100" cy="4351200"/>
           </a:xfrm>
           <a:prstGeom prst="rect">
             <a:avLst/>
@@ -18016,11 +18045,11 @@
         </p:spPr>
         <p:txBody>
           <a:bodyPr anchorCtr="0" anchor="t" bIns="45700" lIns="91425" spcFirstLastPara="1" rIns="91425" wrap="square" tIns="45700">
-            <a:normAutofit/>
+            <a:normAutofit lnSpcReduction="20000"/>
           </a:bodyPr>
           <a:lstStyle/>
           <a:p>
-            <a:pPr indent="-381000" lvl="0" marL="457200" rtl="0" algn="l">
+            <a:pPr indent="0" lvl="0" marL="0" rtl="0" algn="l">
               <a:lnSpc>
                 <a:spcPct val="115000"/>
               </a:lnSpc>
@@ -18030,9 +18059,7 @@
               <a:spcAft>
                 <a:spcPts val="0"/>
               </a:spcAft>
-              <a:buSzPts val="2400"/>
-              <a:buFont typeface="Times New Roman"/>
-              <a:buChar char="•"/>
+              <a:buNone/>
             </a:pPr>
             <a:r>
               <a:rPr lang="en-US">
@@ -18041,7 +18068,7 @@
                 <a:cs typeface="Times New Roman"/>
                 <a:sym typeface="Times New Roman"/>
               </a:rPr>
-              <a:t>A. Laurentini, “The Visual Hull Concept for Silhouette-Based Image Understanding,” IEEE Transactions on Pattern Analysis and Machine Intelligence, vol. 16, no. 2, pp. 150–162, 1994. </a:t>
+              <a:t>[1] A. Laurentini, “The Visual Hull Concept for Silhouette-Based Image Understanding,” IEEE Transactions on Pattern Analysis and Machine Intelligence, vol. 16, no. 2, pp. 150–162, 1994. </a:t>
             </a:r>
             <a:endParaRPr>
               <a:latin typeface="Times New Roman"/>
@@ -18051,7 +18078,7 @@
             </a:endParaRPr>
           </a:p>
           <a:p>
-            <a:pPr indent="-381000" lvl="0" marL="457200" rtl="0" algn="l">
+            <a:pPr indent="0" lvl="0" marL="0" rtl="0" algn="l">
               <a:lnSpc>
                 <a:spcPct val="115000"/>
               </a:lnSpc>
@@ -18061,9 +18088,57 @@
               <a:spcAft>
                 <a:spcPts val="0"/>
               </a:spcAft>
-              <a:buSzPts val="2400"/>
-              <a:buFont typeface="Times New Roman"/>
-              <a:buChar char="•"/>
+              <a:buNone/>
+            </a:pPr>
+            <a:r>
+              <a:rPr lang="en-US" sz="1900" u="sng">
+                <a:solidFill>
+                  <a:schemeClr val="hlink"/>
+                </a:solidFill>
+                <a:latin typeface="Arial"/>
+                <a:ea typeface="Arial"/>
+                <a:cs typeface="Arial"/>
+                <a:sym typeface="Arial"/>
+                <a:hlinkClick r:id="rId3"/>
+              </a:rPr>
+              <a:t>https://www.researchgate.net/publication/324389722/figure/fig3/AS:11431281391286952@1745321870314/Regular-3D-voxel-grid-unoccupied.tif</a:t>
+            </a:r>
+            <a:r>
+              <a:rPr lang="en-US" sz="1900" u="sng">
+                <a:latin typeface="Arial"/>
+                <a:ea typeface="Arial"/>
+                <a:cs typeface="Arial"/>
+                <a:sym typeface="Arial"/>
+              </a:rPr>
+              <a:t>  </a:t>
+            </a:r>
+            <a:br>
+              <a:rPr lang="en-US" sz="1900" u="sng">
+                <a:latin typeface="Arial"/>
+                <a:ea typeface="Arial"/>
+                <a:cs typeface="Arial"/>
+                <a:sym typeface="Arial"/>
+              </a:rPr>
+            </a:br>
+            <a:endParaRPr>
+              <a:latin typeface="Times New Roman"/>
+              <a:ea typeface="Times New Roman"/>
+              <a:cs typeface="Times New Roman"/>
+              <a:sym typeface="Times New Roman"/>
+            </a:endParaRPr>
+          </a:p>
+          <a:p>
+            <a:pPr indent="0" lvl="0" marL="0" rtl="0" algn="l">
+              <a:lnSpc>
+                <a:spcPct val="115000"/>
+              </a:lnSpc>
+              <a:spcBef>
+                <a:spcPts val="0"/>
+              </a:spcBef>
+              <a:spcAft>
+                <a:spcPts val="0"/>
+              </a:spcAft>
+              <a:buNone/>
             </a:pPr>
             <a:r>
               <a:rPr lang="en-US">
@@ -18072,7 +18147,7 @@
                 <a:cs typeface="Times New Roman"/>
                 <a:sym typeface="Times New Roman"/>
               </a:rPr>
-              <a:t>T. Pham, H. Nguyen, and M. Ho, “Multi-View 3D Reconstruction from Silhouettes,” Computer Vision and Image Understanding, vol. 203, 103151, 2021. </a:t>
+              <a:t>[2] T. Pham, H. Nguyen, and M. Ho, “Multi-View 3D Reconstruction from     Silhouettes,” Computer Vision and Image Understanding, vol. 203, 103151, 2021. </a:t>
             </a:r>
             <a:endParaRPr>
               <a:latin typeface="Times New Roman"/>
@@ -18082,7 +18157,7 @@
             </a:endParaRPr>
           </a:p>
           <a:p>
-            <a:pPr indent="0" lvl="0" marL="457200" rtl="0" algn="l">
+            <a:pPr indent="0" lvl="0" marL="0" rtl="0" algn="l">
               <a:lnSpc>
                 <a:spcPct val="115000"/>
               </a:lnSpc>
@@ -18092,35 +18167,20 @@
               <a:spcAft>
                 <a:spcPts val="0"/>
               </a:spcAft>
-              <a:buSzPts val="2595"/>
               <a:buNone/>
             </a:pPr>
             <a:r>
-              <a:t/>
-            </a:r>
-            <a:endParaRPr>
-              <a:latin typeface="Times New Roman"/>
-              <a:ea typeface="Times New Roman"/>
-              <a:cs typeface="Times New Roman"/>
-              <a:sym typeface="Times New Roman"/>
-            </a:endParaRPr>
-          </a:p>
-          <a:p>
-            <a:pPr indent="0" lvl="0" marL="914400" rtl="0" algn="l">
-              <a:lnSpc>
-                <a:spcPct val="90000"/>
-              </a:lnSpc>
-              <a:spcBef>
-                <a:spcPts val="500"/>
-              </a:spcBef>
-              <a:spcAft>
-                <a:spcPts val="0"/>
-              </a:spcAft>
-              <a:buSzPts val="2595"/>
-              <a:buNone/>
-            </a:pPr>
-            <a:r>
-              <a:t/>
+              <a:rPr lang="en-US" sz="1900" u="sng">
+                <a:solidFill>
+                  <a:schemeClr val="hlink"/>
+                </a:solidFill>
+                <a:latin typeface="Arial"/>
+                <a:ea typeface="Arial"/>
+                <a:cs typeface="Arial"/>
+                <a:sym typeface="Arial"/>
+                <a:hlinkClick r:id="rId4"/>
+              </a:rPr>
+              <a:t>https://www.itm-conferences.org/articles/itmconf/pdf/2024/07/itmconf_icacs2024_01010.pdf</a:t>
             </a:r>
             <a:endParaRPr>
               <a:latin typeface="Times New Roman"/>

</xml_diff>